<commit_message>
changes for duplicates and wall presentaTION
</commit_message>
<xml_diff>
--- a/PBU walls.pptx
+++ b/PBU walls.pptx
@@ -204,7 +204,7 @@
           <a:p>
             <a:fld id="{FCE99BB8-CEDC-457A-8B94-A349A5D0E58E}" type="datetimeFigureOut">
               <a:rPr lang="en-SG" smtClean="0"/>
-              <a:t>10/9/2025</a:t>
+              <a:t>16/9/2025</a:t>
             </a:fld>
             <a:endParaRPr lang="en-SG"/>
           </a:p>
@@ -873,7 +873,7 @@
           <a:p>
             <a:fld id="{57CB7D9E-7001-4EF6-B630-F6AE7747FACD}" type="datetimeFigureOut">
               <a:rPr lang="en-SG" smtClean="0"/>
-              <a:t>10/9/2025</a:t>
+              <a:t>16/9/2025</a:t>
             </a:fld>
             <a:endParaRPr lang="en-SG"/>
           </a:p>
@@ -1073,7 +1073,7 @@
           <a:p>
             <a:fld id="{57CB7D9E-7001-4EF6-B630-F6AE7747FACD}" type="datetimeFigureOut">
               <a:rPr lang="en-SG" smtClean="0"/>
-              <a:t>10/9/2025</a:t>
+              <a:t>16/9/2025</a:t>
             </a:fld>
             <a:endParaRPr lang="en-SG"/>
           </a:p>
@@ -1283,7 +1283,7 @@
           <a:p>
             <a:fld id="{57CB7D9E-7001-4EF6-B630-F6AE7747FACD}" type="datetimeFigureOut">
               <a:rPr lang="en-SG" smtClean="0"/>
-              <a:t>10/9/2025</a:t>
+              <a:t>16/9/2025</a:t>
             </a:fld>
             <a:endParaRPr lang="en-SG"/>
           </a:p>
@@ -1483,7 +1483,7 @@
           <a:p>
             <a:fld id="{57CB7D9E-7001-4EF6-B630-F6AE7747FACD}" type="datetimeFigureOut">
               <a:rPr lang="en-SG" smtClean="0"/>
-              <a:t>10/9/2025</a:t>
+              <a:t>16/9/2025</a:t>
             </a:fld>
             <a:endParaRPr lang="en-SG"/>
           </a:p>
@@ -1759,7 +1759,7 @@
           <a:p>
             <a:fld id="{57CB7D9E-7001-4EF6-B630-F6AE7747FACD}" type="datetimeFigureOut">
               <a:rPr lang="en-SG" smtClean="0"/>
-              <a:t>10/9/2025</a:t>
+              <a:t>16/9/2025</a:t>
             </a:fld>
             <a:endParaRPr lang="en-SG"/>
           </a:p>
@@ -2027,7 +2027,7 @@
           <a:p>
             <a:fld id="{57CB7D9E-7001-4EF6-B630-F6AE7747FACD}" type="datetimeFigureOut">
               <a:rPr lang="en-SG" smtClean="0"/>
-              <a:t>10/9/2025</a:t>
+              <a:t>16/9/2025</a:t>
             </a:fld>
             <a:endParaRPr lang="en-SG"/>
           </a:p>
@@ -2442,7 +2442,7 @@
           <a:p>
             <a:fld id="{57CB7D9E-7001-4EF6-B630-F6AE7747FACD}" type="datetimeFigureOut">
               <a:rPr lang="en-SG" smtClean="0"/>
-              <a:t>10/9/2025</a:t>
+              <a:t>16/9/2025</a:t>
             </a:fld>
             <a:endParaRPr lang="en-SG"/>
           </a:p>
@@ -2584,7 +2584,7 @@
           <a:p>
             <a:fld id="{57CB7D9E-7001-4EF6-B630-F6AE7747FACD}" type="datetimeFigureOut">
               <a:rPr lang="en-SG" smtClean="0"/>
-              <a:t>10/9/2025</a:t>
+              <a:t>16/9/2025</a:t>
             </a:fld>
             <a:endParaRPr lang="en-SG"/>
           </a:p>
@@ -2697,7 +2697,7 @@
           <a:p>
             <a:fld id="{57CB7D9E-7001-4EF6-B630-F6AE7747FACD}" type="datetimeFigureOut">
               <a:rPr lang="en-SG" smtClean="0"/>
-              <a:t>10/9/2025</a:t>
+              <a:t>16/9/2025</a:t>
             </a:fld>
             <a:endParaRPr lang="en-SG"/>
           </a:p>
@@ -3010,7 +3010,7 @@
           <a:p>
             <a:fld id="{57CB7D9E-7001-4EF6-B630-F6AE7747FACD}" type="datetimeFigureOut">
               <a:rPr lang="en-SG" smtClean="0"/>
-              <a:t>10/9/2025</a:t>
+              <a:t>16/9/2025</a:t>
             </a:fld>
             <a:endParaRPr lang="en-SG"/>
           </a:p>
@@ -3299,7 +3299,7 @@
           <a:p>
             <a:fld id="{57CB7D9E-7001-4EF6-B630-F6AE7747FACD}" type="datetimeFigureOut">
               <a:rPr lang="en-SG" smtClean="0"/>
-              <a:t>10/9/2025</a:t>
+              <a:t>16/9/2025</a:t>
             </a:fld>
             <a:endParaRPr lang="en-SG"/>
           </a:p>
@@ -3542,7 +3542,7 @@
           <a:p>
             <a:fld id="{57CB7D9E-7001-4EF6-B630-F6AE7747FACD}" type="datetimeFigureOut">
               <a:rPr lang="en-SG" smtClean="0"/>
-              <a:t>10/9/2025</a:t>
+              <a:t>16/9/2025</a:t>
             </a:fld>
             <a:endParaRPr lang="en-SG"/>
           </a:p>
@@ -5118,10 +5118,10 @@
       </p:sp>
       <p:pic>
         <p:nvPicPr>
-          <p:cNvPr id="53" name="Picture 52">
+          <p:cNvPr id="38" name="Picture 37">
             <a:extLst>
               <a:ext uri="{FF2B5EF4-FFF2-40B4-BE49-F238E27FC236}">
-                <a16:creationId xmlns:a16="http://schemas.microsoft.com/office/drawing/2014/main" id="{B7C91280-8B9A-A819-0CF5-52E1670BAF23}"/>
+                <a16:creationId xmlns:a16="http://schemas.microsoft.com/office/drawing/2014/main" id="{0C5FAC87-DBD1-9DD8-7D6B-205D87993ADC}"/>
               </a:ext>
             </a:extLst>
           </p:cNvPr>
@@ -5132,36 +5132,6 @@
         </p:nvPicPr>
         <p:blipFill>
           <a:blip r:embed="rId2"/>
-          <a:stretch>
-            <a:fillRect/>
-          </a:stretch>
-        </p:blipFill>
-        <p:spPr>
-          <a:xfrm>
-            <a:off x="265346" y="3125462"/>
-            <a:ext cx="5830654" cy="1880385"/>
-          </a:xfrm>
-          <a:prstGeom prst="rect">
-            <a:avLst/>
-          </a:prstGeom>
-        </p:spPr>
-      </p:pic>
-      <p:pic>
-        <p:nvPicPr>
-          <p:cNvPr id="38" name="Picture 37">
-            <a:extLst>
-              <a:ext uri="{FF2B5EF4-FFF2-40B4-BE49-F238E27FC236}">
-                <a16:creationId xmlns:a16="http://schemas.microsoft.com/office/drawing/2014/main" id="{0C5FAC87-DBD1-9DD8-7D6B-205D87993ADC}"/>
-              </a:ext>
-            </a:extLst>
-          </p:cNvPr>
-          <p:cNvPicPr>
-            <a:picLocks noChangeAspect="1"/>
-          </p:cNvPicPr>
-          <p:nvPr/>
-        </p:nvPicPr>
-        <p:blipFill>
-          <a:blip r:embed="rId3"/>
           <a:stretch>
             <a:fillRect/>
           </a:stretch>
@@ -5736,6 +5706,36 @@
           </a:p>
         </p:txBody>
       </p:sp>
+      <p:pic>
+        <p:nvPicPr>
+          <p:cNvPr id="20" name="Picture 19">
+            <a:extLst>
+              <a:ext uri="{FF2B5EF4-FFF2-40B4-BE49-F238E27FC236}">
+                <a16:creationId xmlns:a16="http://schemas.microsoft.com/office/drawing/2014/main" id="{771CC790-E45F-56E4-8330-6D1D41A5FD17}"/>
+              </a:ext>
+            </a:extLst>
+          </p:cNvPr>
+          <p:cNvPicPr>
+            <a:picLocks noChangeAspect="1"/>
+          </p:cNvPicPr>
+          <p:nvPr/>
+        </p:nvPicPr>
+        <p:blipFill>
+          <a:blip r:embed="rId3"/>
+          <a:stretch>
+            <a:fillRect/>
+          </a:stretch>
+        </p:blipFill>
+        <p:spPr>
+          <a:xfrm>
+            <a:off x="303387" y="3327650"/>
+            <a:ext cx="6774940" cy="1959874"/>
+          </a:xfrm>
+          <a:prstGeom prst="rect">
+            <a:avLst/>
+          </a:prstGeom>
+        </p:spPr>
+      </p:pic>
     </p:spTree>
     <p:extLst>
       <p:ext uri="{BB962C8B-B14F-4D97-AF65-F5344CB8AC3E}">
@@ -6285,10 +6285,10 @@
       </p:sp>
       <p:pic>
         <p:nvPicPr>
-          <p:cNvPr id="41" name="Picture 40">
+          <p:cNvPr id="26" name="Picture 25">
             <a:extLst>
               <a:ext uri="{FF2B5EF4-FFF2-40B4-BE49-F238E27FC236}">
-                <a16:creationId xmlns:a16="http://schemas.microsoft.com/office/drawing/2014/main" id="{2DFE1596-139E-0758-4CD1-9A677934BA29}"/>
+                <a16:creationId xmlns:a16="http://schemas.microsoft.com/office/drawing/2014/main" id="{FD3169E2-751C-6247-968E-5E9649E039FF}"/>
               </a:ext>
             </a:extLst>
           </p:cNvPr>
@@ -6299,36 +6299,6 @@
         </p:nvPicPr>
         <p:blipFill>
           <a:blip r:embed="rId2"/>
-          <a:stretch>
-            <a:fillRect/>
-          </a:stretch>
-        </p:blipFill>
-        <p:spPr>
-          <a:xfrm>
-            <a:off x="505225" y="3619500"/>
-            <a:ext cx="6797581" cy="900678"/>
-          </a:xfrm>
-          <a:prstGeom prst="rect">
-            <a:avLst/>
-          </a:prstGeom>
-        </p:spPr>
-      </p:pic>
-      <p:pic>
-        <p:nvPicPr>
-          <p:cNvPr id="26" name="Picture 25">
-            <a:extLst>
-              <a:ext uri="{FF2B5EF4-FFF2-40B4-BE49-F238E27FC236}">
-                <a16:creationId xmlns:a16="http://schemas.microsoft.com/office/drawing/2014/main" id="{FD3169E2-751C-6247-968E-5E9649E039FF}"/>
-              </a:ext>
-            </a:extLst>
-          </p:cNvPr>
-          <p:cNvPicPr>
-            <a:picLocks noChangeAspect="1"/>
-          </p:cNvPicPr>
-          <p:nvPr/>
-        </p:nvPicPr>
-        <p:blipFill>
-          <a:blip r:embed="rId3"/>
           <a:stretch>
             <a:fillRect/>
           </a:stretch>
@@ -6553,6 +6523,36 @@
           </a:p>
         </p:txBody>
       </p:sp>
+      <p:pic>
+        <p:nvPicPr>
+          <p:cNvPr id="10" name="Picture 9">
+            <a:extLst>
+              <a:ext uri="{FF2B5EF4-FFF2-40B4-BE49-F238E27FC236}">
+                <a16:creationId xmlns:a16="http://schemas.microsoft.com/office/drawing/2014/main" id="{076882B7-8B39-F40D-C543-1FD66A8A3CF3}"/>
+              </a:ext>
+            </a:extLst>
+          </p:cNvPr>
+          <p:cNvPicPr>
+            <a:picLocks noChangeAspect="1"/>
+          </p:cNvPicPr>
+          <p:nvPr/>
+        </p:nvPicPr>
+        <p:blipFill>
+          <a:blip r:embed="rId3"/>
+          <a:stretch>
+            <a:fillRect/>
+          </a:stretch>
+        </p:blipFill>
+        <p:spPr>
+          <a:xfrm>
+            <a:off x="368045" y="3685032"/>
+            <a:ext cx="7349361" cy="854163"/>
+          </a:xfrm>
+          <a:prstGeom prst="rect">
+            <a:avLst/>
+          </a:prstGeom>
+        </p:spPr>
+      </p:pic>
     </p:spTree>
     <p:extLst>
       <p:ext uri="{BB962C8B-B14F-4D97-AF65-F5344CB8AC3E}">
@@ -7130,36 +7130,6 @@
           </a:prstGeom>
         </p:spPr>
       </p:pic>
-      <p:pic>
-        <p:nvPicPr>
-          <p:cNvPr id="44" name="Picture 43">
-            <a:extLst>
-              <a:ext uri="{FF2B5EF4-FFF2-40B4-BE49-F238E27FC236}">
-                <a16:creationId xmlns:a16="http://schemas.microsoft.com/office/drawing/2014/main" id="{E1B8F530-07E7-DA7A-3BFA-A4C6D2EC8A23}"/>
-              </a:ext>
-            </a:extLst>
-          </p:cNvPr>
-          <p:cNvPicPr>
-            <a:picLocks noChangeAspect="1"/>
-          </p:cNvPicPr>
-          <p:nvPr/>
-        </p:nvPicPr>
-        <p:blipFill>
-          <a:blip r:embed="rId4"/>
-          <a:stretch>
-            <a:fillRect/>
-          </a:stretch>
-        </p:blipFill>
-        <p:spPr>
-          <a:xfrm>
-            <a:off x="505918" y="3514610"/>
-            <a:ext cx="7028144" cy="1158046"/>
-          </a:xfrm>
-          <a:prstGeom prst="rect">
-            <a:avLst/>
-          </a:prstGeom>
-        </p:spPr>
-      </p:pic>
       <p:sp>
         <p:nvSpPr>
           <p:cNvPr id="3" name="TextBox 2">
@@ -7440,6 +7410,36 @@
           </a:p>
         </p:txBody>
       </p:sp>
+      <p:pic>
+        <p:nvPicPr>
+          <p:cNvPr id="12" name="Picture 11">
+            <a:extLst>
+              <a:ext uri="{FF2B5EF4-FFF2-40B4-BE49-F238E27FC236}">
+                <a16:creationId xmlns:a16="http://schemas.microsoft.com/office/drawing/2014/main" id="{91ED136B-EBB0-5E3C-D2B0-FA819E104229}"/>
+              </a:ext>
+            </a:extLst>
+          </p:cNvPr>
+          <p:cNvPicPr>
+            <a:picLocks noChangeAspect="1"/>
+          </p:cNvPicPr>
+          <p:nvPr/>
+        </p:nvPicPr>
+        <p:blipFill>
+          <a:blip r:embed="rId4"/>
+          <a:stretch>
+            <a:fillRect/>
+          </a:stretch>
+        </p:blipFill>
+        <p:spPr>
+          <a:xfrm>
+            <a:off x="476993" y="3361100"/>
+            <a:ext cx="7996949" cy="1158046"/>
+          </a:xfrm>
+          <a:prstGeom prst="rect">
+            <a:avLst/>
+          </a:prstGeom>
+        </p:spPr>
+      </p:pic>
     </p:spTree>
     <p:extLst>
       <p:ext uri="{BB962C8B-B14F-4D97-AF65-F5344CB8AC3E}">
@@ -18200,10 +18200,10 @@
       </p:sp>
       <p:pic>
         <p:nvPicPr>
-          <p:cNvPr id="41" name="Picture 40">
+          <p:cNvPr id="29" name="Picture 28">
             <a:extLst>
               <a:ext uri="{FF2B5EF4-FFF2-40B4-BE49-F238E27FC236}">
-                <a16:creationId xmlns:a16="http://schemas.microsoft.com/office/drawing/2014/main" id="{9E248E88-0FB9-BE12-0970-3D559BFB44FF}"/>
+                <a16:creationId xmlns:a16="http://schemas.microsoft.com/office/drawing/2014/main" id="{AE15FFBA-0A3D-E171-1771-2E2C49EAD217}"/>
               </a:ext>
             </a:extLst>
           </p:cNvPr>
@@ -18214,36 +18214,6 @@
         </p:nvPicPr>
         <p:blipFill>
           <a:blip r:embed="rId3"/>
-          <a:stretch>
-            <a:fillRect/>
-          </a:stretch>
-        </p:blipFill>
-        <p:spPr>
-          <a:xfrm>
-            <a:off x="722811" y="3264408"/>
-            <a:ext cx="7094909" cy="674017"/>
-          </a:xfrm>
-          <a:prstGeom prst="rect">
-            <a:avLst/>
-          </a:prstGeom>
-        </p:spPr>
-      </p:pic>
-      <p:pic>
-        <p:nvPicPr>
-          <p:cNvPr id="29" name="Picture 28">
-            <a:extLst>
-              <a:ext uri="{FF2B5EF4-FFF2-40B4-BE49-F238E27FC236}">
-                <a16:creationId xmlns:a16="http://schemas.microsoft.com/office/drawing/2014/main" id="{AE15FFBA-0A3D-E171-1771-2E2C49EAD217}"/>
-              </a:ext>
-            </a:extLst>
-          </p:cNvPr>
-          <p:cNvPicPr>
-            <a:picLocks noChangeAspect="1"/>
-          </p:cNvPicPr>
-          <p:nvPr/>
-        </p:nvPicPr>
-        <p:blipFill>
-          <a:blip r:embed="rId4"/>
           <a:stretch>
             <a:fillRect/>
           </a:stretch>
@@ -18398,6 +18368,36 @@
           </a:p>
         </p:txBody>
       </p:sp>
+      <p:pic>
+        <p:nvPicPr>
+          <p:cNvPr id="8" name="Picture 7">
+            <a:extLst>
+              <a:ext uri="{FF2B5EF4-FFF2-40B4-BE49-F238E27FC236}">
+                <a16:creationId xmlns:a16="http://schemas.microsoft.com/office/drawing/2014/main" id="{5B761F49-A0AE-2ED3-6978-11D828685830}"/>
+              </a:ext>
+            </a:extLst>
+          </p:cNvPr>
+          <p:cNvPicPr>
+            <a:picLocks noChangeAspect="1"/>
+          </p:cNvPicPr>
+          <p:nvPr/>
+        </p:nvPicPr>
+        <p:blipFill>
+          <a:blip r:embed="rId4"/>
+          <a:stretch>
+            <a:fillRect/>
+          </a:stretch>
+        </p:blipFill>
+        <p:spPr>
+          <a:xfrm>
+            <a:off x="718403" y="3069368"/>
+            <a:ext cx="7360520" cy="553826"/>
+          </a:xfrm>
+          <a:prstGeom prst="rect">
+            <a:avLst/>
+          </a:prstGeom>
+        </p:spPr>
+      </p:pic>
     </p:spTree>
     <p:extLst>
       <p:ext uri="{BB962C8B-B14F-4D97-AF65-F5344CB8AC3E}">
@@ -18883,36 +18883,6 @@
           </a:prstGeom>
         </p:spPr>
       </p:pic>
-      <p:pic>
-        <p:nvPicPr>
-          <p:cNvPr id="34" name="Picture 33">
-            <a:extLst>
-              <a:ext uri="{FF2B5EF4-FFF2-40B4-BE49-F238E27FC236}">
-                <a16:creationId xmlns:a16="http://schemas.microsoft.com/office/drawing/2014/main" id="{AE3CC8B8-B010-A95F-5D1E-24314630BCD4}"/>
-              </a:ext>
-            </a:extLst>
-          </p:cNvPr>
-          <p:cNvPicPr>
-            <a:picLocks noChangeAspect="1"/>
-          </p:cNvPicPr>
-          <p:nvPr/>
-        </p:nvPicPr>
-        <p:blipFill>
-          <a:blip r:embed="rId3"/>
-          <a:stretch>
-            <a:fillRect/>
-          </a:stretch>
-        </p:blipFill>
-        <p:spPr>
-          <a:xfrm>
-            <a:off x="167199" y="3646045"/>
-            <a:ext cx="7396393" cy="571178"/>
-          </a:xfrm>
-          <a:prstGeom prst="rect">
-            <a:avLst/>
-          </a:prstGeom>
-        </p:spPr>
-      </p:pic>
       <p:sp>
         <p:nvSpPr>
           <p:cNvPr id="3" name="TextBox 2">
@@ -19018,6 +18988,36 @@
           </a:p>
         </p:txBody>
       </p:sp>
+      <p:pic>
+        <p:nvPicPr>
+          <p:cNvPr id="7" name="Picture 6">
+            <a:extLst>
+              <a:ext uri="{FF2B5EF4-FFF2-40B4-BE49-F238E27FC236}">
+                <a16:creationId xmlns:a16="http://schemas.microsoft.com/office/drawing/2014/main" id="{77A4E184-9CA8-BA2E-474D-0FCDA5969072}"/>
+              </a:ext>
+            </a:extLst>
+          </p:cNvPr>
+          <p:cNvPicPr>
+            <a:picLocks noChangeAspect="1"/>
+          </p:cNvPicPr>
+          <p:nvPr/>
+        </p:nvPicPr>
+        <p:blipFill>
+          <a:blip r:embed="rId3"/>
+          <a:stretch>
+            <a:fillRect/>
+          </a:stretch>
+        </p:blipFill>
+        <p:spPr>
+          <a:xfrm>
+            <a:off x="167197" y="4063179"/>
+            <a:ext cx="7623817" cy="473414"/>
+          </a:xfrm>
+          <a:prstGeom prst="rect">
+            <a:avLst/>
+          </a:prstGeom>
+        </p:spPr>
+      </p:pic>
     </p:spTree>
     <p:extLst>
       <p:ext uri="{BB962C8B-B14F-4D97-AF65-F5344CB8AC3E}">
@@ -19503,36 +19503,6 @@
           </a:prstGeom>
         </p:spPr>
       </p:pic>
-      <p:pic>
-        <p:nvPicPr>
-          <p:cNvPr id="45" name="Picture 44">
-            <a:extLst>
-              <a:ext uri="{FF2B5EF4-FFF2-40B4-BE49-F238E27FC236}">
-                <a16:creationId xmlns:a16="http://schemas.microsoft.com/office/drawing/2014/main" id="{8F43ACBB-9BE3-4BCB-244C-D0234E97402A}"/>
-              </a:ext>
-            </a:extLst>
-          </p:cNvPr>
-          <p:cNvPicPr>
-            <a:picLocks noChangeAspect="1"/>
-          </p:cNvPicPr>
-          <p:nvPr/>
-        </p:nvPicPr>
-        <p:blipFill>
-          <a:blip r:embed="rId3"/>
-          <a:stretch>
-            <a:fillRect/>
-          </a:stretch>
-        </p:blipFill>
-        <p:spPr>
-          <a:xfrm>
-            <a:off x="439531" y="3622448"/>
-            <a:ext cx="6771801" cy="1189551"/>
-          </a:xfrm>
-          <a:prstGeom prst="rect">
-            <a:avLst/>
-          </a:prstGeom>
-        </p:spPr>
-      </p:pic>
       <p:sp>
         <p:nvSpPr>
           <p:cNvPr id="3" name="TextBox 2">
@@ -19813,6 +19783,36 @@
           </a:p>
         </p:txBody>
       </p:sp>
+      <p:pic>
+        <p:nvPicPr>
+          <p:cNvPr id="12" name="Picture 11">
+            <a:extLst>
+              <a:ext uri="{FF2B5EF4-FFF2-40B4-BE49-F238E27FC236}">
+                <a16:creationId xmlns:a16="http://schemas.microsoft.com/office/drawing/2014/main" id="{29C78CDD-49FE-74E1-D100-1AC455ABC108}"/>
+              </a:ext>
+            </a:extLst>
+          </p:cNvPr>
+          <p:cNvPicPr>
+            <a:picLocks noChangeAspect="1"/>
+          </p:cNvPicPr>
+          <p:nvPr/>
+        </p:nvPicPr>
+        <p:blipFill>
+          <a:blip r:embed="rId3"/>
+          <a:stretch>
+            <a:fillRect/>
+          </a:stretch>
+        </p:blipFill>
+        <p:spPr>
+          <a:xfrm>
+            <a:off x="170537" y="3591664"/>
+            <a:ext cx="7309788" cy="1047619"/>
+          </a:xfrm>
+          <a:prstGeom prst="rect">
+            <a:avLst/>
+          </a:prstGeom>
+        </p:spPr>
+      </p:pic>
     </p:spTree>
     <p:extLst>
       <p:ext uri="{BB962C8B-B14F-4D97-AF65-F5344CB8AC3E}">
@@ -20390,36 +20390,6 @@
           </a:prstGeom>
         </p:spPr>
       </p:pic>
-      <p:pic>
-        <p:nvPicPr>
-          <p:cNvPr id="84" name="Picture 83">
-            <a:extLst>
-              <a:ext uri="{FF2B5EF4-FFF2-40B4-BE49-F238E27FC236}">
-                <a16:creationId xmlns:a16="http://schemas.microsoft.com/office/drawing/2014/main" id="{425B1C47-251A-AC87-6911-58571788D74E}"/>
-              </a:ext>
-            </a:extLst>
-          </p:cNvPr>
-          <p:cNvPicPr>
-            <a:picLocks noChangeAspect="1"/>
-          </p:cNvPicPr>
-          <p:nvPr/>
-        </p:nvPicPr>
-        <p:blipFill>
-          <a:blip r:embed="rId4"/>
-          <a:stretch>
-            <a:fillRect/>
-          </a:stretch>
-        </p:blipFill>
-        <p:spPr>
-          <a:xfrm>
-            <a:off x="220060" y="2211932"/>
-            <a:ext cx="6193623" cy="2540662"/>
-          </a:xfrm>
-          <a:prstGeom prst="rect">
-            <a:avLst/>
-          </a:prstGeom>
-        </p:spPr>
-      </p:pic>
       <p:sp>
         <p:nvSpPr>
           <p:cNvPr id="3" name="TextBox 2">
@@ -21155,6 +21125,36 @@
           </a:p>
         </p:txBody>
       </p:sp>
+      <p:pic>
+        <p:nvPicPr>
+          <p:cNvPr id="30" name="Picture 29">
+            <a:extLst>
+              <a:ext uri="{FF2B5EF4-FFF2-40B4-BE49-F238E27FC236}">
+                <a16:creationId xmlns:a16="http://schemas.microsoft.com/office/drawing/2014/main" id="{822B5F82-8B31-890F-0998-BE24A6C3FFE3}"/>
+              </a:ext>
+            </a:extLst>
+          </p:cNvPr>
+          <p:cNvPicPr>
+            <a:picLocks noChangeAspect="1"/>
+          </p:cNvPicPr>
+          <p:nvPr/>
+        </p:nvPicPr>
+        <p:blipFill>
+          <a:blip r:embed="rId4"/>
+          <a:stretch>
+            <a:fillRect/>
+          </a:stretch>
+        </p:blipFill>
+        <p:spPr>
+          <a:xfrm>
+            <a:off x="82208" y="3056185"/>
+            <a:ext cx="6316687" cy="2154805"/>
+          </a:xfrm>
+          <a:prstGeom prst="rect">
+            <a:avLst/>
+          </a:prstGeom>
+        </p:spPr>
+      </p:pic>
     </p:spTree>
     <p:extLst>
       <p:ext uri="{BB962C8B-B14F-4D97-AF65-F5344CB8AC3E}">

</xml_diff>